<commit_message>
SSLC r4 QA: fix Conger/Rufer panel overlap + Rufer ledger note, add 5-yr per holder, remove unverified 'Exos Midland', employees text fit
</commit_message>
<xml_diff>
--- a/drafts/Exos_SSLC_Board_Offer_Overview_2026-10-12_r4.pptx
+++ b/drafts/Exos_SSLC_Board_Offer_Overview_2026-10-12_r4.pptx
@@ -9455,7 +9455,7 @@
               <a:buNone/>
             </a:pPr>
             <a:r>
-              <a:rPr lang="en-US" sz="1300" dirty="0">
+              <a:rPr lang="en-US" sz="1150" dirty="0">
                 <a:solidFill>
                   <a:srgbClr val="CCCCCC"/>
                 </a:solidFill>
@@ -9475,7 +9475,7 @@
               <a:buNone/>
             </a:pPr>
             <a:r>
-              <a:rPr lang="en-US" sz="1300" dirty="0">
+              <a:rPr lang="en-US" sz="1150" dirty="0">
                 <a:solidFill>
                   <a:srgbClr val="CCCCCC"/>
                 </a:solidFill>
@@ -9835,7 +9835,7 @@
                 </a:solidFill>
                 <a:latin typeface="Calibri"/>
               </a:rPr>
-              <a:t>CA: New lease near SSLC — 25,000–35,000 sf,</a:t>
+              <a:t>CA: New lease near the current SSLC site, 25,000–35,000 sq ft with high ceilings, to shift manufacturing and support expansion.</a:t>
             </a:r>
           </a:p>
           <a:p>
@@ -9846,7 +9846,7 @@
                 </a:solidFill>
                 <a:latin typeface="Calibri"/>
               </a:rPr>
-              <a:t>high bay, to expand mfg. capacity at close.</a:t>
+              <a:t/>
             </a:r>
           </a:p>
           <a:p>
@@ -9857,6 +9857,17 @@
                 </a:solidFill>
                 <a:latin typeface="Calibri"/>
               </a:rPr>
+              <a:t>TX: Expansion in Texas to support Exos rocket builds, funded under the same PIPE financing.</a:t>
+            </a:r>
+          </a:p>
+          <a:p>
+            <a:r>
+              <a:rPr lang="en-US" sz="1000" dirty="0">
+                <a:solidFill>
+                  <a:srgbClr val="CCCCCC"/>
+                </a:solidFill>
+                <a:latin typeface="Calibri"/>
+              </a:rPr>
               <a:t/>
             </a:r>
           </a:p>
@@ -9864,55 +9875,22 @@
             <a:r>
               <a:rPr lang="en-US" sz="1000" dirty="0">
                 <a:solidFill>
+                  <a:srgbClr val="F26A21"/>
+                </a:solidFill>
+                <a:latin typeface="Calibri"/>
+              </a:rPr>
+              <a:t>$1.0M EAI (Exos stock) to key SSLC personnel</a:t>
+            </a:r>
+          </a:p>
+          <a:p>
+            <a:r>
+              <a:rPr lang="en-US" sz="1000" dirty="0">
+                <a:solidFill>
                   <a:srgbClr val="CCCCCC"/>
                 </a:solidFill>
                 <a:latin typeface="Calibri"/>
               </a:rPr>
-              <a:t>TX: Expansion at Exos Midland funded under</a:t>
-            </a:r>
-          </a:p>
-          <a:p>
-            <a:r>
-              <a:rPr lang="en-US" sz="1000" dirty="0">
-                <a:solidFill>
-                  <a:srgbClr val="CCCCCC"/>
-                </a:solidFill>
-                <a:latin typeface="Calibri"/>
-              </a:rPr>
-              <a:t>the same PIPE as acquisition financing.</a:t>
-            </a:r>
-          </a:p>
-          <a:p>
-            <a:r>
-              <a:rPr lang="en-US" sz="1000" dirty="0">
-                <a:solidFill>
-                  <a:srgbClr val="CCCCCC"/>
-                </a:solidFill>
-                <a:latin typeface="Calibri"/>
-              </a:rPr>
-              <a:t/>
-            </a:r>
-          </a:p>
-          <a:p>
-            <a:r>
-              <a:rPr lang="en-US" sz="1000" dirty="0">
-                <a:solidFill>
-                  <a:srgbClr val="F26A21"/>
-                </a:solidFill>
-                <a:latin typeface="Calibri"/>
-              </a:rPr>
-              <a:t>$1.0M EAI (Exos stock) to key SSLC personnel</a:t>
-            </a:r>
-          </a:p>
-          <a:p>
-            <a:r>
-              <a:rPr lang="en-US" sz="1000" dirty="0">
-                <a:solidFill>
-                  <a:srgbClr val="CCCCCC"/>
-                </a:solidFill>
-                <a:latin typeface="Calibri"/>
-              </a:rPr>
-              <a:t>at financing close (not pro-rata to cap table).</a:t>
+              <a:t>at financing close (not pro-rata to the cap table).</a:t>
             </a:r>
           </a:p>
         </p:txBody>
@@ -28956,7 +28934,7 @@
         <p:spPr>
           <a:xfrm>
             <a:off x="4736592" y="795528"/>
-            <a:ext cx="1920240" cy="201168"/>
+            <a:ext cx="1965960" cy="201168"/>
           </a:xfrm>
           <a:prstGeom prst="rect">
             <a:avLst/>
@@ -28977,7 +28955,7 @@
                 </a:solidFill>
                 <a:latin typeface="Calibri"/>
               </a:rPr>
-              <a:t>8.37% of SSLC  ·  10.21% of payout distributions</a:t>
+              <a:t>8.37% of SSLC · 10.21% of payout</a:t>
             </a:r>
           </a:p>
         </p:txBody>
@@ -29012,7 +28990,7 @@
                 </a:solidFill>
                 <a:latin typeface="Calibri"/>
               </a:rPr>
-              <a:t>Cert #3 (44,000) + Cert #43 (29,000)</a:t>
+              <a:t>Certs #3 (44K) + #43 (29K)</a:t>
             </a:r>
           </a:p>
         </p:txBody>
@@ -29026,7 +29004,7 @@
         <p:spPr>
           <a:xfrm>
             <a:off x="4736592" y="1170432"/>
-            <a:ext cx="1920240" cy="219456"/>
+            <a:ext cx="1188720" cy="219456"/>
           </a:xfrm>
           <a:prstGeom prst="rect">
             <a:avLst/>
@@ -29047,7 +29025,7 @@
                 </a:solidFill>
                 <a:latin typeface="Calibri"/>
               </a:rPr>
-              <a:t>At close  (as booked):</a:t>
+              <a:t>Close, as booked</a:t>
             </a:r>
           </a:p>
         </p:txBody>
@@ -29060,8 +29038,8 @@
         </p:nvSpPr>
         <p:spPr>
           <a:xfrm>
-            <a:off x="7068312" y="1170432"/>
-            <a:ext cx="1920240" cy="219456"/>
+            <a:off x="5897880" y="1170432"/>
+            <a:ext cx="777240" cy="219456"/>
           </a:xfrm>
           <a:prstGeom prst="rect">
             <a:avLst/>
@@ -29096,7 +29074,7 @@
         <p:spPr>
           <a:xfrm>
             <a:off x="4736592" y="1399032"/>
-            <a:ext cx="1920240" cy="219456"/>
+            <a:ext cx="1188720" cy="219456"/>
           </a:xfrm>
           <a:prstGeom prst="rect">
             <a:avLst/>
@@ -29117,7 +29095,7 @@
                 </a:solidFill>
                 <a:latin typeface="Calibri"/>
               </a:rPr>
-              <a:t>At close  (Step 1 corrected):</a:t>
+              <a:t>Close, Step 1</a:t>
             </a:r>
           </a:p>
         </p:txBody>
@@ -29130,8 +29108,8 @@
         </p:nvSpPr>
         <p:spPr>
           <a:xfrm>
-            <a:off x="7068312" y="1399032"/>
-            <a:ext cx="1920240" cy="219456"/>
+            <a:off x="5897880" y="1399032"/>
+            <a:ext cx="777240" cy="219456"/>
           </a:xfrm>
           <a:prstGeom prst="rect">
             <a:avLst/>
@@ -29166,7 +29144,7 @@
         <p:spPr>
           <a:xfrm>
             <a:off x="4736592" y="1627632"/>
-            <a:ext cx="1920240" cy="219456"/>
+            <a:ext cx="1188720" cy="219456"/>
           </a:xfrm>
           <a:prstGeom prst="rect">
             <a:avLst/>
@@ -29187,7 +29165,7 @@
                 </a:solidFill>
                 <a:latin typeface="Calibri"/>
               </a:rPr>
-              <a:t>At close  (Step 1+2):</a:t>
+              <a:t>Close, Step 1+2</a:t>
             </a:r>
           </a:p>
         </p:txBody>
@@ -29200,8 +29178,8 @@
         </p:nvSpPr>
         <p:spPr>
           <a:xfrm>
-            <a:off x="7068312" y="1627632"/>
-            <a:ext cx="1920240" cy="219456"/>
+            <a:off x="5897880" y="1627632"/>
+            <a:ext cx="777240" cy="219456"/>
           </a:xfrm>
           <a:prstGeom prst="rect">
             <a:avLst/>
@@ -29235,8 +29213,8 @@
         </p:nvSpPr>
         <p:spPr>
           <a:xfrm>
-            <a:off x="4736592" y="1856232"/>
-            <a:ext cx="1920240" cy="219456"/>
+            <a:off x="4736592" y="1856231"/>
+            <a:ext cx="1188720" cy="219456"/>
           </a:xfrm>
           <a:prstGeom prst="rect">
             <a:avLst/>
@@ -29257,7 +29235,7 @@
                 </a:solidFill>
                 <a:latin typeface="Calibri"/>
               </a:rPr>
-              <a:t>At close  (Step 3):</a:t>
+              <a:t>Close, Step 3</a:t>
             </a:r>
           </a:p>
         </p:txBody>
@@ -29270,8 +29248,8 @@
         </p:nvSpPr>
         <p:spPr>
           <a:xfrm>
-            <a:off x="7068312" y="1856232"/>
-            <a:ext cx="1920240" cy="219456"/>
+            <a:off x="5897880" y="1856231"/>
+            <a:ext cx="777240" cy="219456"/>
           </a:xfrm>
           <a:prstGeom prst="rect">
             <a:avLst/>
@@ -29305,8 +29283,8 @@
         </p:nvSpPr>
         <p:spPr>
           <a:xfrm>
-            <a:off x="4736592" y="2121408"/>
-            <a:ext cx="1920240" cy="384048"/>
+            <a:off x="4736592" y="2103120"/>
+            <a:ext cx="1965960" cy="411480"/>
           </a:xfrm>
           <a:prstGeom prst="rect">
             <a:avLst/>
@@ -29327,8 +29305,7 @@
                 </a:solidFill>
                 <a:latin typeface="Calibri"/>
               </a:rPr>
-              <a:t>⚠ SSLC’s 6/3/2026 ledger lists only 29K shares (cert #43); cert #3 (44K) is missing.
-Motion 2 corrects the share register.</a:t>
+              <a:t>5-yr ≈ $403K (8.2× paid-in). 6/3 ledger omits cert #3.</a:t>
             </a:r>
           </a:p>
         </p:txBody>
@@ -30526,7 +30503,7 @@
         <p:spPr>
           <a:xfrm>
             <a:off x="6812280" y="795528"/>
-            <a:ext cx="2103120" cy="201168"/>
+            <a:ext cx="2194560" cy="201168"/>
           </a:xfrm>
           <a:prstGeom prst="rect">
             <a:avLst/>
@@ -30546,7 +30523,7 @@
                 </a:solidFill>
                 <a:latin typeface="Calibri"/>
               </a:rPr>
-              <a:t>10.43% of SSLC  ·  12.73% of distributions</a:t>
+              <a:t>10.43% of SSLC · 12.73% of payout</a:t>
             </a:r>
           </a:p>
         </p:txBody>
@@ -30637,7 +30614,7 @@
         <p:spPr>
           <a:xfrm>
             <a:off x="6812280" y="1170432"/>
-            <a:ext cx="1463040" cy="219456"/>
+            <a:ext cx="1234440" cy="219456"/>
           </a:xfrm>
           <a:prstGeom prst="rect">
             <a:avLst/>
@@ -30657,7 +30634,7 @@
                 </a:solidFill>
                 <a:latin typeface="Calibri"/>
               </a:rPr>
-              <a:t>At close  (as booked):</a:t>
+              <a:t>Close, as booked</a:t>
             </a:r>
           </a:p>
         </p:txBody>
@@ -30670,8 +30647,8 @@
         </p:nvSpPr>
         <p:spPr>
           <a:xfrm>
-            <a:off x="8229600" y="1170432"/>
-            <a:ext cx="777240" cy="219456"/>
+            <a:off x="8138160" y="1170432"/>
+            <a:ext cx="822960" cy="219456"/>
           </a:xfrm>
           <a:prstGeom prst="rect">
             <a:avLst/>
@@ -30684,6 +30661,7 @@
           </a:bodyPr>
           <a:lstStyle/>
           <a:p>
+            <a:pPr algn="r"/>
             <a:r>
               <a:rPr lang="en-US" sz="1100" dirty="0" b="1">
                 <a:solidFill>
@@ -30705,7 +30683,7 @@
         <p:spPr>
           <a:xfrm>
             <a:off x="6812280" y="1399032"/>
-            <a:ext cx="1463040" cy="219456"/>
+            <a:ext cx="1234440" cy="219456"/>
           </a:xfrm>
           <a:prstGeom prst="rect">
             <a:avLst/>
@@ -30725,7 +30703,7 @@
                 </a:solidFill>
                 <a:latin typeface="Calibri"/>
               </a:rPr>
-              <a:t>At close  (Step 1 corrected):</a:t>
+              <a:t>Close, Step 1</a:t>
             </a:r>
           </a:p>
         </p:txBody>
@@ -30738,8 +30716,8 @@
         </p:nvSpPr>
         <p:spPr>
           <a:xfrm>
-            <a:off x="8229600" y="1399032"/>
-            <a:ext cx="777240" cy="219456"/>
+            <a:off x="8138160" y="1399032"/>
+            <a:ext cx="822960" cy="219456"/>
           </a:xfrm>
           <a:prstGeom prst="rect">
             <a:avLst/>
@@ -30752,6 +30730,7 @@
           </a:bodyPr>
           <a:lstStyle/>
           <a:p>
+            <a:pPr algn="r"/>
             <a:r>
               <a:rPr lang="en-US" sz="1100" dirty="0" b="1">
                 <a:solidFill>
@@ -30773,7 +30752,7 @@
         <p:spPr>
           <a:xfrm>
             <a:off x="6812280" y="1627632"/>
-            <a:ext cx="1463040" cy="219456"/>
+            <a:ext cx="1234440" cy="219456"/>
           </a:xfrm>
           <a:prstGeom prst="rect">
             <a:avLst/>
@@ -30793,7 +30772,7 @@
                 </a:solidFill>
                 <a:latin typeface="Calibri"/>
               </a:rPr>
-              <a:t>At close  (Step 1+2):</a:t>
+              <a:t>Close, Step 1+2</a:t>
             </a:r>
           </a:p>
         </p:txBody>
@@ -30806,8 +30785,8 @@
         </p:nvSpPr>
         <p:spPr>
           <a:xfrm>
-            <a:off x="8229600" y="1627632"/>
-            <a:ext cx="777240" cy="219456"/>
+            <a:off x="8138160" y="1627632"/>
+            <a:ext cx="822960" cy="219456"/>
           </a:xfrm>
           <a:prstGeom prst="rect">
             <a:avLst/>
@@ -30820,6 +30799,7 @@
           </a:bodyPr>
           <a:lstStyle/>
           <a:p>
+            <a:pPr algn="r"/>
             <a:r>
               <a:rPr lang="en-US" sz="1100" dirty="0" b="1">
                 <a:solidFill>
@@ -30841,7 +30821,7 @@
         <p:spPr>
           <a:xfrm>
             <a:off x="6812280" y="1856231"/>
-            <a:ext cx="1463040" cy="219456"/>
+            <a:ext cx="1234440" cy="219456"/>
           </a:xfrm>
           <a:prstGeom prst="rect">
             <a:avLst/>
@@ -30861,7 +30841,7 @@
                 </a:solidFill>
                 <a:latin typeface="Calibri"/>
               </a:rPr>
-              <a:t>At close  (Step 3):</a:t>
+              <a:t>Close, Step 3</a:t>
             </a:r>
           </a:p>
         </p:txBody>
@@ -30874,8 +30854,8 @@
         </p:nvSpPr>
         <p:spPr>
           <a:xfrm>
-            <a:off x="8229600" y="1856231"/>
-            <a:ext cx="777240" cy="219456"/>
+            <a:off x="8138160" y="1856231"/>
+            <a:ext cx="822960" cy="219456"/>
           </a:xfrm>
           <a:prstGeom prst="rect">
             <a:avLst/>
@@ -30888,6 +30868,7 @@
           </a:bodyPr>
           <a:lstStyle/>
           <a:p>
+            <a:pPr algn="r"/>
             <a:r>
               <a:rPr lang="en-US" sz="1100" dirty="0" b="1">
                 <a:solidFill>
@@ -30908,16 +30889,16 @@
         </p:nvSpPr>
         <p:spPr>
           <a:xfrm>
-            <a:off x="6812280" y="2121408"/>
-            <a:ext cx="2103120" cy="384048"/>
-          </a:xfrm>
-          <a:prstGeom prst="rect">
-            <a:avLst/>
-          </a:prstGeom>
-          <a:noFill/>
-        </p:spPr>
-        <p:txBody>
-          <a:bodyPr wrap="sq" anchor="t">
+            <a:off x="6812280" y="2103120"/>
+            <a:ext cx="2194560" cy="411480"/>
+          </a:xfrm>
+          <a:prstGeom prst="rect">
+            <a:avLst/>
+          </a:prstGeom>
+          <a:noFill/>
+        </p:spPr>
+        <p:txBody>
+          <a:bodyPr wrap="square" anchor="t">
             <a:spAutoFit/>
           </a:bodyPr>
           <a:lstStyle/>
@@ -30929,7 +30910,7 @@
                 </a:solidFill>
                 <a:latin typeface="Calibri"/>
               </a:rPr>
-              <a:t>Rufer not in 6/3/2026 ledger; register shows 91,000 shares. Motion 2 corrects.</a:t>
+              <a:t>5-yr ≈ $502K (16× paid-in). Ledger matches register.</a:t>
             </a:r>
           </a:p>
         </p:txBody>

</xml_diff>